<commit_message>
Sim-Review M04: 9 VPs + Artefakte neu + sim_review true
Co-Authored-By: Claude Fable 5 <noreply@anthropic.com>
</commit_message>
<xml_diff>
--- a/protected-downloads/praesentation/M04.pptx
+++ b/protected-downloads/praesentation/M04.pptx
@@ -7276,7 +7276,7 @@
                 </a:solidFill>
                 <a:latin typeface="Consolas"/>
               </a:rPr>
-              <a:t>15–30       </a:t>
+              <a:t>15–32       </a:t>
             </a:r>
             <a:r>
               <a:rPr sz="1500" b="1">
@@ -7313,7 +7313,7 @@
                 </a:solidFill>
                 <a:latin typeface="Consolas"/>
               </a:rPr>
-              <a:t>30–45       </a:t>
+              <a:t>32–47       </a:t>
             </a:r>
             <a:r>
               <a:rPr sz="1500" b="1">
@@ -7350,7 +7350,7 @@
                 </a:solidFill>
                 <a:latin typeface="Consolas"/>
               </a:rPr>
-              <a:t>45–65       </a:t>
+              <a:t>47–72       </a:t>
             </a:r>
             <a:r>
               <a:rPr sz="1500" b="1">
@@ -7387,7 +7387,7 @@
                 </a:solidFill>
                 <a:latin typeface="Consolas"/>
               </a:rPr>
-              <a:t>65–80       </a:t>
+              <a:t>72–90       </a:t>
             </a:r>
             <a:r>
               <a:rPr sz="1500" b="1">
@@ -7424,7 +7424,7 @@
                 </a:solidFill>
                 <a:latin typeface="Consolas"/>
               </a:rPr>
-              <a:t>80–88       </a:t>
+              <a:t>90–98       </a:t>
             </a:r>
             <a:r>
               <a:rPr sz="1500" b="1">
@@ -7461,7 +7461,7 @@
                 </a:solidFill>
                 <a:latin typeface="Consolas"/>
               </a:rPr>
-              <a:t>88–90       </a:t>
+              <a:t>98–100      </a:t>
             </a:r>
             <a:r>
               <a:rPr sz="1500" b="1">

</xml_diff>

<commit_message>
M-Track Batch 2: M04 Deck (Web/Workbook)
Co-Authored-By: Claude Fable 5 <noreply@anthropic.com>
</commit_message>
<xml_diff>
--- a/protected-downloads/praesentation/M04.pptx
+++ b/protected-downloads/praesentation/M04.pptx
@@ -18,6 +18,7 @@
     <p:sldId id="266" r:id="rId18"/>
     <p:sldId id="267" r:id="rId19"/>
     <p:sldId id="268" r:id="rId20"/>
+    <p:sldId id="269" r:id="rId21"/>
   </p:sldIdLst>
   <p:sldSz cx="12188952" cy="6858000" type="screen4x3"/>
   <p:notesSz cx="6858000" cy="9144000"/>
@@ -584,7 +585,7 @@
           <a:lstStyle/>
           <a:p>
             <a:r>
-              <a:t>Siehe Trainerhandbuch (Sektion 3) für Moderationshinweise, Timing und erwartete Teilnehmerreaktionen.</a:t>
+              <a:t>Einstieg: „Woran haben Sie zuletzt gemerkt, dass es bei einem Kunden kippt – bevor es die Zahlen zeigten?"</a:t>
             </a:r>
           </a:p>
         </p:txBody>
@@ -654,7 +655,7 @@
           <a:lstStyle/>
           <a:p>
             <a:r>
-              <a:t>Siehe Trainerhandbuch (Sektion 3) für Moderationshinweise, Timing und erwartete Teilnehmerreaktionen.</a:t>
+              <a:t>Kernbotschaft: in der Strategie-/Ertragskrise ist der Kunde noch gestaltbar; in der Liquiditätskrise wird es Schadensbegrenzung.</a:t>
             </a:r>
           </a:p>
         </p:txBody>
@@ -724,7 +725,7 @@
           <a:lstStyle/>
           <a:p>
             <a:r>
-              <a:t>Siehe Trainerhandbuch (Sektion 3) für Moderationshinweise, Timing und erwartete Teilnehmerreaktionen.</a:t>
+              <a:t>Die Ampel-Checkliste bündelt beide Dimensionen zu einer Gesamtbewertung.</a:t>
             </a:r>
           </a:p>
         </p:txBody>
@@ -794,7 +795,7 @@
           <a:lstStyle/>
           <a:p>
             <a:r>
-              <a:t>Siehe Trainerhandbuch (Sektion 3) für Moderationshinweise, Timing und erwartete Teilnehmerreaktionen.</a:t>
+              <a:t>Revisionssichere agree-Dokumentation als Mindeststandard. Die Handlungsempfehlung verbindet Signal und Reaktion.</a:t>
             </a:r>
           </a:p>
         </p:txBody>
@@ -864,7 +865,12 @@
           <a:lstStyle/>
           <a:p>
             <a:r>
-              <a:t>Siehe Trainerhandbuch (Sektion 3) für Moderationshinweise, Timing und erwartete Teilnehmerreaktionen.</a:t>
+              <a:t>AB Musterlösung (Trainer-Version)</a:t>
+            </a:r>
+          </a:p>
+          <a:p>
+            <a:r>
+              <a:t>Renner: mehrere gelbe/rote Signale (Kontokorrent-Auslastung, verzögerter Jahresabschluss). Ergebnis: rote Ampel, Meldung Teamleiter + Marktfolge, revisionssicherer Vermerk.</a:t>
             </a:r>
           </a:p>
         </p:txBody>
@@ -934,57 +940,77 @@
           <a:lstStyle/>
           <a:p>
             <a:r>
-              <a:t>Musterlösung (Trainer-Version)</a:t>
-            </a:r>
-          </a:p>
-          <a:p>
-            <a:r>
-              <a:t>AB-1 Ergebnisse:</a:t>
-            </a:r>
-          </a:p>
-          <a:p>
-            <a:r>
-              <a:t>Gesamtpunktzahl: mindestens 13–15 / 20 → Rot-Einstufung</a:t>
-            </a:r>
-          </a:p>
-          <a:p>
-            <a:r>
-              <a:t>AB-2 Musterlösung:</a:t>
-            </a:r>
-          </a:p>
-          <a:p>
-            <a:r>
-              <a:t>Krisenphase 2 (Latente Krise): Krise ist vorhanden (Leverage 5,4x, KK 91 %, fallende EBITDA-Marge über 3 Jahre), aber noch kein Zahlungsausfall. Übergang zu Phase 3 droht ohne Gegenmaßnahmen.</a:t>
-            </a:r>
-          </a:p>
-          <a:p>
-            <a:r>
-              <a:t>Dominantes Signal: Leverage 5,4x bei fallendem EBITDA — der Schuldendienst ist gefährdet. Ergänzend: KK-Inanspruchnahme 91 % = Liquiditätspuffer nahezu aufgebraucht.</a:t>
-            </a:r>
-          </a:p>
-          <a:p>
-            <a:r>
-              <a:t>Eskalation Rot: Sofortige Meldung an Teamleiter (&lt; 48 Stunden). Keine eigenständigen Zusagen oder Linienerhöhungen. Marktfolge zur Sicherheitenbewertung einschalten.</a:t>
-            </a:r>
-          </a:p>
-          <a:p>
-            <a:r>
-              <a:t>Musterformulierungen Aufgabe A4:</a:t>
-            </a:r>
-          </a:p>
-          <a:p>
-            <a:r>
-              <a:t>1. „Wie entwickelt sich der Auftragsbestand bei Ihrem Hauptkunden — haben Sie Aufträge für die nächsten 6 Monate gesichert?"</a:t>
-            </a:r>
-          </a:p>
-          <a:p>
-            <a:r>
-              <a:t>2. „Ihr Jahresabschluss liegt uns noch nicht vor. Können wir Ihren Steuerberater direkt kontaktieren?"</a:t>
-            </a:r>
-          </a:p>
-          <a:p>
-            <a:r>
-              <a:t>3. „Wie haben Sie die langfristige Führung des Unternehmens geregelt — haben Sie schon konkrete Überlegungen zur Nachfolge?"</a:t>
+              <a:t>Überleitung zum Selbstcheck und Transfer.</a:t>
+            </a:r>
+          </a:p>
+        </p:txBody>
+      </p:sp>
+      <p:sp>
+        <p:nvSpPr>
+          <p:cNvPr id="4" name="Slide Number Placeholder 3"/>
+          <p:cNvSpPr>
+            <a:spLocks noGrp="1"/>
+          </p:cNvSpPr>
+          <p:nvPr>
+            <p:ph type="sldNum" idx="5" sz="quarter"/>
+          </p:nvPr>
+        </p:nvSpPr>
+        <p:spPr/>
+      </p:sp>
+    </p:spTree>
+  </p:cSld>
+  <p:clrMapOvr>
+    <a:masterClrMapping/>
+  </p:clrMapOvr>
+</p:notes>
+</file>
+
+<file path=ppt/notesSlides/notesSlide8.xml><?xml version="1.0" encoding="utf-8"?>
+<p:notes xmlns:a="http://schemas.openxmlformats.org/drawingml/2006/main" xmlns:p="http://schemas.openxmlformats.org/presentationml/2006/main" xmlns:r="http://schemas.openxmlformats.org/officeDocument/2006/relationships">
+  <p:cSld>
+    <p:spTree>
+      <p:nvGrpSpPr>
+        <p:cNvPr id="1" name=""/>
+        <p:cNvGrpSpPr/>
+        <p:nvPr/>
+      </p:nvGrpSpPr>
+      <p:grpSpPr>
+        <a:xfrm>
+          <a:off x="0" y="0"/>
+          <a:ext cx="0" cy="0"/>
+          <a:chOff x="0" y="0"/>
+          <a:chExt cx="0" cy="0"/>
+        </a:xfrm>
+      </p:grpSpPr>
+      <p:sp>
+        <p:nvSpPr>
+          <p:cNvPr id="2" name="Slide Image Placeholder 1"/>
+          <p:cNvSpPr>
+            <a:spLocks noGrp="1"/>
+          </p:cNvSpPr>
+          <p:nvPr>
+            <p:ph type="sldImg" idx="2"/>
+          </p:nvPr>
+        </p:nvSpPr>
+        <p:spPr/>
+      </p:sp>
+      <p:sp>
+        <p:nvSpPr>
+          <p:cNvPr id="3" name="Notes Placeholder 2"/>
+          <p:cNvSpPr>
+            <a:spLocks noGrp="1"/>
+          </p:cNvSpPr>
+          <p:nvPr>
+            <p:ph type="body" idx="3" sz="quarter"/>
+          </p:nvPr>
+        </p:nvSpPr>
+        <p:spPr/>
+        <p:txBody>
+          <a:bodyPr/>
+          <a:lstStyle/>
+          <a:p>
+            <a:r>
+              <a:t>Selbstcheck nach 4 Wochen als Transferanker.</a:t>
             </a:r>
           </a:p>
         </p:txBody>
@@ -4716,7 +4742,7 @@
                 </a:solidFill>
                 <a:latin typeface="Arial"/>
               </a:rPr>
-              <a:t>Frühwarn-Ampelkarte</a:t>
+              <a:t>Handlungsempfehlung: vom Warnsignal zur Eskalation</a:t>
             </a:r>
           </a:p>
         </p:txBody>
@@ -4780,8 +4806,8 @@
         </p:blipFill>
         <p:spPr>
           <a:xfrm>
-            <a:off x="2163921" y="1325880"/>
-            <a:ext cx="7861110" cy="4937760"/>
+            <a:off x="2303489" y="1325880"/>
+            <a:ext cx="7581973" cy="4937760"/>
           </a:xfrm>
           <a:prstGeom prst="rect">
             <a:avLst/>
@@ -4934,7 +4960,7 @@
             <a:avLst/>
           </a:prstGeom>
           <a:solidFill>
-            <a:srgbClr val="EDEDF3"/>
+            <a:srgbClr val="1F2C56"/>
           </a:solidFill>
           <a:ln>
             <a:noFill/>
@@ -4964,57 +4990,14 @@
       </p:sp>
       <p:sp>
         <p:nvSpPr>
-          <p:cNvPr id="3" name="Rectangle 2"/>
-          <p:cNvSpPr/>
-          <p:nvPr/>
-        </p:nvSpPr>
-        <p:spPr>
-          <a:xfrm>
-            <a:off x="0" y="0"/>
-            <a:ext cx="12188952" cy="50292"/>
-          </a:xfrm>
-          <a:prstGeom prst="rect">
-            <a:avLst/>
-          </a:prstGeom>
-          <a:solidFill>
-            <a:srgbClr val="1F2C56"/>
-          </a:solidFill>
-          <a:ln>
-            <a:noFill/>
-          </a:ln>
-        </p:spPr>
-        <p:style>
-          <a:lnRef idx="1">
-            <a:schemeClr val="accent1"/>
-          </a:lnRef>
-          <a:fillRef idx="3">
-            <a:schemeClr val="accent1"/>
-          </a:fillRef>
-          <a:effectRef idx="2">
-            <a:schemeClr val="accent1"/>
-          </a:effectRef>
-          <a:fontRef idx="minor">
-            <a:schemeClr val="lt1"/>
-          </a:fontRef>
-        </p:style>
-        <p:txBody>
-          <a:bodyPr rtlCol="0" anchor="ctr"/>
-          <a:lstStyle/>
-          <a:p>
-            <a:pPr algn="ctr"/>
-          </a:p>
-        </p:txBody>
-      </p:sp>
-      <p:sp>
-        <p:nvSpPr>
-          <p:cNvPr id="4" name="TextBox 3"/>
+          <p:cNvPr id="3" name="TextBox 2"/>
           <p:cNvSpPr txBox="1"/>
           <p:nvPr/>
         </p:nvSpPr>
         <p:spPr>
           <a:xfrm>
-            <a:off x="685800" y="109728"/>
-            <a:ext cx="10817352" cy="228600"/>
+            <a:off x="685800" y="2377440"/>
+            <a:ext cx="10817352" cy="365760"/>
           </a:xfrm>
           <a:prstGeom prst="rect">
             <a:avLst/>
@@ -5029,70 +5012,27 @@
           <a:p>
             <a:pPr algn="l"/>
             <a:r>
-              <a:rPr sz="750">
-                <a:solidFill>
-                  <a:srgbClr val="78808C"/>
+              <a:rPr sz="1200">
+                <a:solidFill>
+                  <a:srgbClr val="D9C089"/>
                 </a:solidFill>
                 <a:latin typeface="Consolas"/>
               </a:rPr>
-              <a:t>M04  ·  INHALT</a:t>
-            </a:r>
-          </a:p>
-        </p:txBody>
-      </p:sp>
-      <p:sp>
-        <p:nvSpPr>
-          <p:cNvPr id="5" name="Rectangle 4"/>
+              <a:t>FALLARBEIT</a:t>
+            </a:r>
+          </a:p>
+        </p:txBody>
+      </p:sp>
+      <p:sp>
+        <p:nvSpPr>
+          <p:cNvPr id="4" name="Rectangle 3"/>
           <p:cNvSpPr/>
           <p:nvPr/>
         </p:nvSpPr>
         <p:spPr>
           <a:xfrm>
-            <a:off x="0" y="1234440"/>
-            <a:ext cx="12188952" cy="12700"/>
-          </a:xfrm>
-          <a:prstGeom prst="rect">
-            <a:avLst/>
-          </a:prstGeom>
-          <a:solidFill>
-            <a:srgbClr val="D8DFE4"/>
-          </a:solidFill>
-          <a:ln>
-            <a:noFill/>
-          </a:ln>
-        </p:spPr>
-        <p:style>
-          <a:lnRef idx="1">
-            <a:schemeClr val="accent1"/>
-          </a:lnRef>
-          <a:fillRef idx="3">
-            <a:schemeClr val="accent1"/>
-          </a:fillRef>
-          <a:effectRef idx="2">
-            <a:schemeClr val="accent1"/>
-          </a:effectRef>
-          <a:fontRef idx="minor">
-            <a:schemeClr val="lt1"/>
-          </a:fontRef>
-        </p:style>
-        <p:txBody>
-          <a:bodyPr rtlCol="0" anchor="ctr"/>
-          <a:lstStyle/>
-          <a:p>
-            <a:pPr algn="ctr"/>
-          </a:p>
-        </p:txBody>
-      </p:sp>
-      <p:sp>
-        <p:nvSpPr>
-          <p:cNvPr id="6" name="Rectangle 5"/>
-          <p:cNvSpPr/>
-          <p:nvPr/>
-        </p:nvSpPr>
-        <p:spPr>
-          <a:xfrm>
-            <a:off x="685800" y="502920"/>
-            <a:ext cx="36576" cy="658368"/>
+            <a:off x="685800" y="2788920"/>
+            <a:ext cx="548640" cy="38100"/>
           </a:xfrm>
           <a:prstGeom prst="rect">
             <a:avLst/>
@@ -5128,14 +5068,14 @@
       </p:sp>
       <p:sp>
         <p:nvSpPr>
-          <p:cNvPr id="7" name="TextBox 6"/>
+          <p:cNvPr id="5" name="TextBox 4"/>
           <p:cNvSpPr txBox="1"/>
           <p:nvPr/>
         </p:nvSpPr>
         <p:spPr>
           <a:xfrm>
-            <a:off x="813816" y="502920"/>
-            <a:ext cx="10634472" cy="685800"/>
+            <a:off x="685800" y="3017520"/>
+            <a:ext cx="10817352" cy="1463040"/>
           </a:xfrm>
           <a:prstGeom prst="rect">
             <a:avLst/>
@@ -5150,27 +5090,27 @@
           <a:p>
             <a:pPr algn="l"/>
             <a:r>
-              <a:rPr sz="2400" b="1" i="0">
-                <a:solidFill>
-                  <a:srgbClr val="1F2C56"/>
+              <a:rPr sz="4000" b="1" i="0">
+                <a:solidFill>
+                  <a:srgbClr val="FFFFFF"/>
                 </a:solidFill>
                 <a:latin typeface="Arial"/>
               </a:rPr>
-              <a:t>Eskalationspfade – Wer handelt wann?</a:t>
-            </a:r>
-          </a:p>
-        </p:txBody>
-      </p:sp>
-      <p:sp>
-        <p:nvSpPr>
-          <p:cNvPr id="8" name="TextBox 7"/>
+              <a:t>Praxiscase Renner Metallverarbeitung</a:t>
+            </a:r>
+          </a:p>
+        </p:txBody>
+      </p:sp>
+      <p:sp>
+        <p:nvSpPr>
+          <p:cNvPr id="6" name="TextBox 5"/>
           <p:cNvSpPr txBox="1"/>
           <p:nvPr/>
         </p:nvSpPr>
         <p:spPr>
           <a:xfrm>
-            <a:off x="685800" y="1417320"/>
-            <a:ext cx="10817352" cy="4892040"/>
+            <a:off x="685800" y="4480560"/>
+            <a:ext cx="8653881" cy="1280160"/>
           </a:xfrm>
           <a:prstGeom prst="rect">
             <a:avLst/>
@@ -5178,103 +5118,34 @@
           <a:noFill/>
         </p:spPr>
         <p:txBody>
-          <a:bodyPr wrap="square" anchor="ctr">
+          <a:bodyPr wrap="square">
             <a:spAutoFit/>
           </a:bodyPr>
           <a:lstStyle/>
           <a:p>
-            <a:pPr marL="177800" indent="-177800">
-              <a:spcBef>
-                <a:spcPts val="600"/>
-              </a:spcBef>
-              <a:spcAft>
-                <a:spcPts val="200"/>
-              </a:spcAft>
-            </a:pPr>
-            <a:r>
-              <a:rPr sz="1200" i="1">
-                <a:solidFill>
-                  <a:srgbClr val="3D5466"/>
+            <a:pPr algn="l"/>
+            <a:r>
+              <a:rPr sz="1600" b="0" i="0">
+                <a:solidFill>
+                  <a:srgbClr val="C8D2E6"/>
                 </a:solidFill>
                 <a:latin typeface="Arial"/>
               </a:rPr>
-              <a:t>→  Dokumentation in agree: Jeder Gelb- oder Rot-Befund wird im Risikovermerk dokumentiert: Datum, Indikator, Bewertung, nächste Maßnahme, Verantwortlicher. Das ist Revisionspflicht .</a:t>
-            </a:r>
-          </a:p>
-          <a:p>
-            <a:pPr marL="190500" indent="-190500">
-              <a:spcBef>
-                <a:spcPts val="400"/>
-              </a:spcBef>
-              <a:spcAft>
-                <a:spcPts val="200"/>
-              </a:spcAft>
-            </a:pPr>
-            <a:r>
-              <a:rPr sz="1300">
-                <a:solidFill>
-                  <a:srgbClr val="3D5466"/>
-                </a:solidFill>
-                <a:latin typeface="Arial"/>
-              </a:rPr>
-              <a:t>▸  Die folgende Karte verknüpft die erkannten Risikosignale direkt mit konkreten Handlungsschritten und zeigt, wann welche Maßnahme angemessen ist.</a:t>
-            </a:r>
-          </a:p>
-        </p:txBody>
-      </p:sp>
-      <p:sp>
-        <p:nvSpPr>
-          <p:cNvPr id="9" name="Rectangle 8"/>
-          <p:cNvSpPr/>
-          <p:nvPr/>
-        </p:nvSpPr>
-        <p:spPr>
-          <a:xfrm>
-            <a:off x="0" y="6510528"/>
-            <a:ext cx="12188952" cy="347472"/>
-          </a:xfrm>
-          <a:prstGeom prst="rect">
-            <a:avLst/>
-          </a:prstGeom>
-          <a:solidFill>
-            <a:srgbClr val="0A1937"/>
-          </a:solidFill>
-          <a:ln>
-            <a:noFill/>
-          </a:ln>
-        </p:spPr>
-        <p:style>
-          <a:lnRef idx="1">
-            <a:schemeClr val="accent1"/>
-          </a:lnRef>
-          <a:fillRef idx="3">
-            <a:schemeClr val="accent1"/>
-          </a:fillRef>
-          <a:effectRef idx="2">
-            <a:schemeClr val="accent1"/>
-          </a:effectRef>
-          <a:fontRef idx="minor">
-            <a:schemeClr val="lt1"/>
-          </a:fontRef>
-        </p:style>
-        <p:txBody>
-          <a:bodyPr rtlCol="0" anchor="ctr"/>
-          <a:lstStyle/>
-          <a:p>
-            <a:pPr algn="ctr"/>
-          </a:p>
-        </p:txBody>
-      </p:sp>
-      <p:sp>
-        <p:nvSpPr>
-          <p:cNvPr id="10" name="TextBox 9"/>
+              <a:t>Die Ampel-Checkliste auf einen echten Kunden anwenden.</a:t>
+            </a:r>
+          </a:p>
+        </p:txBody>
+      </p:sp>
+      <p:sp>
+        <p:nvSpPr>
+          <p:cNvPr id="7" name="TextBox 6"/>
           <p:cNvSpPr txBox="1"/>
           <p:nvPr/>
         </p:nvSpPr>
         <p:spPr>
           <a:xfrm>
-            <a:off x="685800" y="6583680"/>
-            <a:ext cx="6490411" cy="256032"/>
+            <a:off x="685800" y="6355080"/>
+            <a:ext cx="10817352" cy="274320"/>
           </a:xfrm>
           <a:prstGeom prst="rect">
             <a:avLst/>
@@ -5291,7 +5162,7 @@
             <a:r>
               <a:rPr sz="700">
                 <a:solidFill>
-                  <a:srgbClr val="A0B4D2"/>
+                  <a:srgbClr val="8CA0C3"/>
                 </a:solidFill>
                 <a:latin typeface="Consolas"/>
               </a:rPr>
@@ -5333,7 +5204,7 @@
             <a:avLst/>
           </a:prstGeom>
           <a:solidFill>
-            <a:srgbClr val="FFFFFF"/>
+            <a:srgbClr val="EDEDF3"/>
           </a:solidFill>
           <a:ln>
             <a:noFill/>
@@ -5434,43 +5305,51 @@
                 </a:solidFill>
                 <a:latin typeface="Consolas"/>
               </a:rPr>
-              <a:t>M04  ·  SCHAUBILD</a:t>
-            </a:r>
-          </a:p>
-        </p:txBody>
-      </p:sp>
-      <p:sp>
-        <p:nvSpPr>
-          <p:cNvPr id="5" name="TextBox 4"/>
-          <p:cNvSpPr txBox="1"/>
-          <p:nvPr/>
-        </p:nvSpPr>
-        <p:spPr>
-          <a:xfrm>
-            <a:off x="685800" y="502920"/>
-            <a:ext cx="10817352" cy="594360"/>
-          </a:xfrm>
-          <a:prstGeom prst="rect">
-            <a:avLst/>
-          </a:prstGeom>
-          <a:noFill/>
-        </p:spPr>
-        <p:txBody>
-          <a:bodyPr wrap="square">
-            <a:spAutoFit/>
-          </a:bodyPr>
-          <a:lstStyle/>
-          <a:p>
-            <a:pPr algn="l"/>
-            <a:r>
-              <a:rPr sz="2000" b="1" i="0">
-                <a:solidFill>
-                  <a:srgbClr val="1F2C56"/>
-                </a:solidFill>
-                <a:latin typeface="Arial"/>
-              </a:rPr>
-              <a:t>Handlungsempfehlung Wenn-Dann</a:t>
-            </a:r>
+              <a:t>M04  ·  ARBEITSBLATT</a:t>
+            </a:r>
+          </a:p>
+        </p:txBody>
+      </p:sp>
+      <p:sp>
+        <p:nvSpPr>
+          <p:cNvPr id="5" name="Rectangle 4"/>
+          <p:cNvSpPr/>
+          <p:nvPr/>
+        </p:nvSpPr>
+        <p:spPr>
+          <a:xfrm>
+            <a:off x="0" y="1234440"/>
+            <a:ext cx="12188952" cy="12700"/>
+          </a:xfrm>
+          <a:prstGeom prst="rect">
+            <a:avLst/>
+          </a:prstGeom>
+          <a:solidFill>
+            <a:srgbClr val="D8DFE4"/>
+          </a:solidFill>
+          <a:ln>
+            <a:noFill/>
+          </a:ln>
+        </p:spPr>
+        <p:style>
+          <a:lnRef idx="1">
+            <a:schemeClr val="accent1"/>
+          </a:lnRef>
+          <a:fillRef idx="3">
+            <a:schemeClr val="accent1"/>
+          </a:fillRef>
+          <a:effectRef idx="2">
+            <a:schemeClr val="accent1"/>
+          </a:effectRef>
+          <a:fontRef idx="minor">
+            <a:schemeClr val="lt1"/>
+          </a:fontRef>
+        </p:style>
+        <p:txBody>
+          <a:bodyPr rtlCol="0" anchor="ctr"/>
+          <a:lstStyle/>
+          <a:p>
+            <a:pPr algn="ctr"/>
           </a:p>
         </p:txBody>
       </p:sp>
@@ -5482,8 +5361,8 @@
         </p:nvSpPr>
         <p:spPr>
           <a:xfrm>
-            <a:off x="685800" y="1143000"/>
-            <a:ext cx="10817352" cy="25400"/>
+            <a:off x="685800" y="502920"/>
+            <a:ext cx="36576" cy="658368"/>
           </a:xfrm>
           <a:prstGeom prst="rect">
             <a:avLst/>
@@ -5517,33 +5396,202 @@
           </a:p>
         </p:txBody>
       </p:sp>
-      <p:pic>
-        <p:nvPicPr>
-          <p:cNvPr id="7" name="Picture 6" descr="image.png"/>
-          <p:cNvPicPr>
-            <a:picLocks noChangeAspect="1"/>
-          </p:cNvPicPr>
-          <p:nvPr/>
-        </p:nvPicPr>
-        <p:blipFill>
-          <a:blip r:embed="rId2"/>
-          <a:stretch>
-            <a:fillRect/>
-          </a:stretch>
-        </p:blipFill>
-        <p:spPr>
-          <a:xfrm>
-            <a:off x="2303489" y="1325880"/>
-            <a:ext cx="7581973" cy="4937760"/>
-          </a:xfrm>
-          <a:prstGeom prst="rect">
-            <a:avLst/>
-          </a:prstGeom>
-        </p:spPr>
-      </p:pic>
-      <p:sp>
-        <p:nvSpPr>
-          <p:cNvPr id="8" name="Rectangle 7"/>
+      <p:sp>
+        <p:nvSpPr>
+          <p:cNvPr id="7" name="TextBox 6"/>
+          <p:cNvSpPr txBox="1"/>
+          <p:nvPr/>
+        </p:nvSpPr>
+        <p:spPr>
+          <a:xfrm>
+            <a:off x="813816" y="502920"/>
+            <a:ext cx="10634472" cy="685800"/>
+          </a:xfrm>
+          <a:prstGeom prst="rect">
+            <a:avLst/>
+          </a:prstGeom>
+          <a:noFill/>
+        </p:spPr>
+        <p:txBody>
+          <a:bodyPr wrap="square">
+            <a:spAutoFit/>
+          </a:bodyPr>
+          <a:lstStyle/>
+          <a:p>
+            <a:pPr algn="l"/>
+            <a:r>
+              <a:rPr sz="2400" b="1" i="0">
+                <a:solidFill>
+                  <a:srgbClr val="1F2C56"/>
+                </a:solidFill>
+                <a:latin typeface="Arial"/>
+              </a:rPr>
+              <a:t>Praxiscase Renner bearbeiten</a:t>
+            </a:r>
+          </a:p>
+        </p:txBody>
+      </p:sp>
+      <p:sp>
+        <p:nvSpPr>
+          <p:cNvPr id="8" name="TextBox 7"/>
+          <p:cNvSpPr txBox="1"/>
+          <p:nvPr/>
+        </p:nvSpPr>
+        <p:spPr>
+          <a:xfrm>
+            <a:off x="685800" y="1554480"/>
+            <a:ext cx="10817352" cy="3840480"/>
+          </a:xfrm>
+          <a:prstGeom prst="rect">
+            <a:avLst/>
+          </a:prstGeom>
+          <a:noFill/>
+        </p:spPr>
+        <p:txBody>
+          <a:bodyPr wrap="square">
+            <a:spAutoFit/>
+          </a:bodyPr>
+          <a:lstStyle/>
+          <a:p>
+            <a:pPr marL="190500" indent="-190500">
+              <a:spcBef>
+                <a:spcPts val="400"/>
+              </a:spcBef>
+              <a:spcAft>
+                <a:spcPts val="200"/>
+              </a:spcAft>
+            </a:pPr>
+            <a:r>
+              <a:rPr sz="1400">
+                <a:solidFill>
+                  <a:srgbClr val="3D5466"/>
+                </a:solidFill>
+                <a:latin typeface="Arial"/>
+              </a:rPr>
+              <a:t>▸  Füllen Sie die Ampel-Checkliste für die Renner Metallverarbeitung GmbH aus (AB-1).</a:t>
+            </a:r>
+          </a:p>
+          <a:p>
+            <a:pPr marL="190500" indent="-190500">
+              <a:spcBef>
+                <a:spcPts val="400"/>
+              </a:spcBef>
+              <a:spcAft>
+                <a:spcPts val="200"/>
+              </a:spcAft>
+            </a:pPr>
+            <a:r>
+              <a:rPr sz="1400">
+                <a:solidFill>
+                  <a:srgbClr val="3D5466"/>
+                </a:solidFill>
+                <a:latin typeface="Arial"/>
+              </a:rPr>
+              <a:t>▸  Bestimmen Sie die Krisenphase und die passenden Frühwarnindikatoren.</a:t>
+            </a:r>
+          </a:p>
+          <a:p>
+            <a:pPr marL="190500" indent="-190500">
+              <a:spcBef>
+                <a:spcPts val="400"/>
+              </a:spcBef>
+              <a:spcAft>
+                <a:spcPts val="200"/>
+              </a:spcAft>
+            </a:pPr>
+            <a:r>
+              <a:rPr sz="1400">
+                <a:solidFill>
+                  <a:srgbClr val="3D5466"/>
+                </a:solidFill>
+                <a:latin typeface="Arial"/>
+              </a:rPr>
+              <a:t>▸  Leiten Sie Maßnahmen und den Eskalationspfad ab (AB-2).</a:t>
+            </a:r>
+          </a:p>
+        </p:txBody>
+      </p:sp>
+      <p:sp>
+        <p:nvSpPr>
+          <p:cNvPr id="9" name="Rectangle 8"/>
+          <p:cNvSpPr/>
+          <p:nvPr/>
+        </p:nvSpPr>
+        <p:spPr>
+          <a:xfrm>
+            <a:off x="685800" y="5486400"/>
+            <a:ext cx="10817352" cy="640080"/>
+          </a:xfrm>
+          <a:prstGeom prst="rect">
+            <a:avLst/>
+          </a:prstGeom>
+          <a:solidFill>
+            <a:srgbClr val="1F2C56"/>
+          </a:solidFill>
+          <a:ln>
+            <a:noFill/>
+          </a:ln>
+        </p:spPr>
+        <p:style>
+          <a:lnRef idx="1">
+            <a:schemeClr val="accent1"/>
+          </a:lnRef>
+          <a:fillRef idx="3">
+            <a:schemeClr val="accent1"/>
+          </a:fillRef>
+          <a:effectRef idx="2">
+            <a:schemeClr val="accent1"/>
+          </a:effectRef>
+          <a:fontRef idx="minor">
+            <a:schemeClr val="lt1"/>
+          </a:fontRef>
+        </p:style>
+        <p:txBody>
+          <a:bodyPr rtlCol="0" anchor="ctr"/>
+          <a:lstStyle/>
+          <a:p>
+            <a:pPr algn="ctr"/>
+          </a:p>
+        </p:txBody>
+      </p:sp>
+      <p:sp>
+        <p:nvSpPr>
+          <p:cNvPr id="10" name="TextBox 9"/>
+          <p:cNvSpPr txBox="1"/>
+          <p:nvPr/>
+        </p:nvSpPr>
+        <p:spPr>
+          <a:xfrm>
+            <a:off x="868680" y="5596128"/>
+            <a:ext cx="10451592" cy="457200"/>
+          </a:xfrm>
+          <a:prstGeom prst="rect">
+            <a:avLst/>
+          </a:prstGeom>
+          <a:noFill/>
+        </p:spPr>
+        <p:txBody>
+          <a:bodyPr wrap="square">
+            <a:spAutoFit/>
+          </a:bodyPr>
+          <a:lstStyle/>
+          <a:p>
+            <a:pPr algn="l"/>
+            <a:r>
+              <a:rPr sz="1300" b="1" i="0">
+                <a:solidFill>
+                  <a:srgbClr val="FFFFFF"/>
+                </a:solidFill>
+                <a:latin typeface="Arial"/>
+              </a:rPr>
+              <a:t>→  Bearbeitung im Teilnehmer-Workbook (Arbeitsblatt mit Ausfüllfeldern)</a:t>
+            </a:r>
+          </a:p>
+        </p:txBody>
+      </p:sp>
+      <p:sp>
+        <p:nvSpPr>
+          <p:cNvPr id="11" name="Rectangle 10"/>
           <p:cNvSpPr/>
           <p:nvPr/>
         </p:nvSpPr>
@@ -5586,7 +5634,7 @@
       </p:sp>
       <p:sp>
         <p:nvSpPr>
-          <p:cNvPr id="9" name="TextBox 8"/>
+          <p:cNvPr id="12" name="TextBox 11"/>
           <p:cNvSpPr txBox="1"/>
           <p:nvPr/>
         </p:nvSpPr>
@@ -5615,41 +5663,6 @@
                 <a:latin typeface="Consolas"/>
               </a:rPr>
               <a:t>FKB Campus  ·  M04</a:t>
-            </a:r>
-          </a:p>
-        </p:txBody>
-      </p:sp>
-      <p:sp>
-        <p:nvSpPr>
-          <p:cNvPr id="10" name="TextBox 9"/>
-          <p:cNvSpPr txBox="1"/>
-          <p:nvPr/>
-        </p:nvSpPr>
-        <p:spPr>
-          <a:xfrm>
-            <a:off x="7176211" y="6583680"/>
-            <a:ext cx="4326940" cy="256032"/>
-          </a:xfrm>
-          <a:prstGeom prst="rect">
-            <a:avLst/>
-          </a:prstGeom>
-          <a:noFill/>
-        </p:spPr>
-        <p:txBody>
-          <a:bodyPr wrap="none">
-            <a:spAutoFit/>
-          </a:bodyPr>
-          <a:lstStyle/>
-          <a:p>
-            <a:pPr algn="r"/>
-            <a:r>
-              <a:rPr sz="700">
-                <a:solidFill>
-                  <a:srgbClr val="A0B4D2"/>
-                </a:solidFill>
-                <a:latin typeface="Consolas"/>
-              </a:rPr>
-              <a:t>Schaubild</a:t>
             </a:r>
           </a:p>
         </p:txBody>
@@ -5788,7 +5801,7 @@
                 </a:solidFill>
                 <a:latin typeface="Consolas"/>
               </a:rPr>
-              <a:t>M04  ·  ARBEITSBLATT</a:t>
+              <a:t>M04  ·  INHALT</a:t>
             </a:r>
           </a:p>
         </p:txBody>
@@ -5909,7 +5922,7 @@
                 </a:solidFill>
                 <a:latin typeface="Arial"/>
               </a:rPr>
-              <a:t>Praxiscase: Renner Metallverarbeitung GmbH</a:t>
+              <a:t>Prinzip dieses Moduls</a:t>
             </a:r>
           </a:p>
         </p:txBody>
@@ -5922,8 +5935,8 @@
         </p:nvSpPr>
         <p:spPr>
           <a:xfrm>
-            <a:off x="685800" y="1554480"/>
-            <a:ext cx="10817352" cy="3840480"/>
+            <a:off x="685800" y="1417320"/>
+            <a:ext cx="10817352" cy="4892040"/>
           </a:xfrm>
           <a:prstGeom prst="rect">
             <a:avLst/>
@@ -5931,10 +5944,29 @@
           <a:noFill/>
         </p:spPr>
         <p:txBody>
-          <a:bodyPr wrap="square">
+          <a:bodyPr wrap="square" anchor="ctr">
             <a:spAutoFit/>
           </a:bodyPr>
           <a:lstStyle/>
+          <a:p>
+            <a:pPr marL="177800" indent="-177800">
+              <a:spcBef>
+                <a:spcPts val="600"/>
+              </a:spcBef>
+              <a:spcAft>
+                <a:spcPts val="200"/>
+              </a:spcAft>
+            </a:pPr>
+            <a:r>
+              <a:rPr sz="1200" i="1">
+                <a:solidFill>
+                  <a:srgbClr val="3D5466"/>
+                </a:solidFill>
+                <a:latin typeface="Arial"/>
+              </a:rPr>
+              <a:t>→  Das erste Warnsignal steht selten in der Bilanz – meist im Kontokorrent.</a:t>
+            </a:r>
+          </a:p>
           <a:p>
             <a:pPr marL="190500" indent="-190500">
               <a:spcBef>
@@ -5945,15 +5977,376 @@
               </a:spcAft>
             </a:pPr>
             <a:r>
-              <a:rPr sz="1400">
+              <a:rPr sz="1300">
                 <a:solidFill>
                   <a:srgbClr val="3D5466"/>
                 </a:solidFill>
                 <a:latin typeface="Arial"/>
               </a:rPr>
-              <a:t>▸  Unternehmensprofil:</a:t>
-            </a:r>
-          </a:p>
+              <a:t>▸  Qualitative Frühindikatoren laufen den Kennzahlen voraus; reagiere auf das schwache Signal, nicht erst auf den Schaden.</a:t>
+            </a:r>
+          </a:p>
+        </p:txBody>
+      </p:sp>
+      <p:sp>
+        <p:nvSpPr>
+          <p:cNvPr id="9" name="Rectangle 8"/>
+          <p:cNvSpPr/>
+          <p:nvPr/>
+        </p:nvSpPr>
+        <p:spPr>
+          <a:xfrm>
+            <a:off x="0" y="6510528"/>
+            <a:ext cx="12188952" cy="347472"/>
+          </a:xfrm>
+          <a:prstGeom prst="rect">
+            <a:avLst/>
+          </a:prstGeom>
+          <a:solidFill>
+            <a:srgbClr val="0A1937"/>
+          </a:solidFill>
+          <a:ln>
+            <a:noFill/>
+          </a:ln>
+        </p:spPr>
+        <p:style>
+          <a:lnRef idx="1">
+            <a:schemeClr val="accent1"/>
+          </a:lnRef>
+          <a:fillRef idx="3">
+            <a:schemeClr val="accent1"/>
+          </a:fillRef>
+          <a:effectRef idx="2">
+            <a:schemeClr val="accent1"/>
+          </a:effectRef>
+          <a:fontRef idx="minor">
+            <a:schemeClr val="lt1"/>
+          </a:fontRef>
+        </p:style>
+        <p:txBody>
+          <a:bodyPr rtlCol="0" anchor="ctr"/>
+          <a:lstStyle/>
+          <a:p>
+            <a:pPr algn="ctr"/>
+          </a:p>
+        </p:txBody>
+      </p:sp>
+      <p:sp>
+        <p:nvSpPr>
+          <p:cNvPr id="10" name="TextBox 9"/>
+          <p:cNvSpPr txBox="1"/>
+          <p:nvPr/>
+        </p:nvSpPr>
+        <p:spPr>
+          <a:xfrm>
+            <a:off x="685800" y="6583680"/>
+            <a:ext cx="6490411" cy="256032"/>
+          </a:xfrm>
+          <a:prstGeom prst="rect">
+            <a:avLst/>
+          </a:prstGeom>
+          <a:noFill/>
+        </p:spPr>
+        <p:txBody>
+          <a:bodyPr wrap="none">
+            <a:spAutoFit/>
+          </a:bodyPr>
+          <a:lstStyle/>
+          <a:p>
+            <a:pPr algn="l"/>
+            <a:r>
+              <a:rPr sz="700">
+                <a:solidFill>
+                  <a:srgbClr val="A0B4D2"/>
+                </a:solidFill>
+                <a:latin typeface="Consolas"/>
+              </a:rPr>
+              <a:t>FKB Campus  ·  M04</a:t>
+            </a:r>
+          </a:p>
+        </p:txBody>
+      </p:sp>
+    </p:spTree>
+  </p:cSld>
+  <p:clrMapOvr>
+    <a:masterClrMapping/>
+  </p:clrMapOvr>
+</p:sld>
+</file>
+
+<file path=ppt/slides/slide14.xml><?xml version="1.0" encoding="utf-8"?>
+<p:sld xmlns:a="http://schemas.openxmlformats.org/drawingml/2006/main" xmlns:p="http://schemas.openxmlformats.org/presentationml/2006/main" xmlns:r="http://schemas.openxmlformats.org/officeDocument/2006/relationships">
+  <p:cSld>
+    <p:spTree>
+      <p:nvGrpSpPr>
+        <p:cNvPr id="1" name=""/>
+        <p:cNvGrpSpPr/>
+        <p:nvPr/>
+      </p:nvGrpSpPr>
+      <p:grpSpPr/>
+      <p:sp>
+        <p:nvSpPr>
+          <p:cNvPr id="2" name="Rectangle 1"/>
+          <p:cNvSpPr/>
+          <p:nvPr/>
+        </p:nvSpPr>
+        <p:spPr>
+          <a:xfrm>
+            <a:off x="0" y="0"/>
+            <a:ext cx="12188952" cy="6858000"/>
+          </a:xfrm>
+          <a:prstGeom prst="rect">
+            <a:avLst/>
+          </a:prstGeom>
+          <a:solidFill>
+            <a:srgbClr val="EDEDF3"/>
+          </a:solidFill>
+          <a:ln>
+            <a:noFill/>
+          </a:ln>
+        </p:spPr>
+        <p:style>
+          <a:lnRef idx="1">
+            <a:schemeClr val="accent1"/>
+          </a:lnRef>
+          <a:fillRef idx="3">
+            <a:schemeClr val="accent1"/>
+          </a:fillRef>
+          <a:effectRef idx="2">
+            <a:schemeClr val="accent1"/>
+          </a:effectRef>
+          <a:fontRef idx="minor">
+            <a:schemeClr val="lt1"/>
+          </a:fontRef>
+        </p:style>
+        <p:txBody>
+          <a:bodyPr rtlCol="0" anchor="ctr"/>
+          <a:lstStyle/>
+          <a:p>
+            <a:pPr algn="ctr"/>
+          </a:p>
+        </p:txBody>
+      </p:sp>
+      <p:sp>
+        <p:nvSpPr>
+          <p:cNvPr id="3" name="Rectangle 2"/>
+          <p:cNvSpPr/>
+          <p:nvPr/>
+        </p:nvSpPr>
+        <p:spPr>
+          <a:xfrm>
+            <a:off x="0" y="0"/>
+            <a:ext cx="12188952" cy="50292"/>
+          </a:xfrm>
+          <a:prstGeom prst="rect">
+            <a:avLst/>
+          </a:prstGeom>
+          <a:solidFill>
+            <a:srgbClr val="1F2C56"/>
+          </a:solidFill>
+          <a:ln>
+            <a:noFill/>
+          </a:ln>
+        </p:spPr>
+        <p:style>
+          <a:lnRef idx="1">
+            <a:schemeClr val="accent1"/>
+          </a:lnRef>
+          <a:fillRef idx="3">
+            <a:schemeClr val="accent1"/>
+          </a:fillRef>
+          <a:effectRef idx="2">
+            <a:schemeClr val="accent1"/>
+          </a:effectRef>
+          <a:fontRef idx="minor">
+            <a:schemeClr val="lt1"/>
+          </a:fontRef>
+        </p:style>
+        <p:txBody>
+          <a:bodyPr rtlCol="0" anchor="ctr"/>
+          <a:lstStyle/>
+          <a:p>
+            <a:pPr algn="ctr"/>
+          </a:p>
+        </p:txBody>
+      </p:sp>
+      <p:sp>
+        <p:nvSpPr>
+          <p:cNvPr id="4" name="TextBox 3"/>
+          <p:cNvSpPr txBox="1"/>
+          <p:nvPr/>
+        </p:nvSpPr>
+        <p:spPr>
+          <a:xfrm>
+            <a:off x="685800" y="109728"/>
+            <a:ext cx="10817352" cy="228600"/>
+          </a:xfrm>
+          <a:prstGeom prst="rect">
+            <a:avLst/>
+          </a:prstGeom>
+          <a:noFill/>
+        </p:spPr>
+        <p:txBody>
+          <a:bodyPr wrap="none">
+            <a:spAutoFit/>
+          </a:bodyPr>
+          <a:lstStyle/>
+          <a:p>
+            <a:pPr algn="l"/>
+            <a:r>
+              <a:rPr sz="750">
+                <a:solidFill>
+                  <a:srgbClr val="78808C"/>
+                </a:solidFill>
+                <a:latin typeface="Consolas"/>
+              </a:rPr>
+              <a:t>M04  ·  INHALT</a:t>
+            </a:r>
+          </a:p>
+        </p:txBody>
+      </p:sp>
+      <p:sp>
+        <p:nvSpPr>
+          <p:cNvPr id="5" name="Rectangle 4"/>
+          <p:cNvSpPr/>
+          <p:nvPr/>
+        </p:nvSpPr>
+        <p:spPr>
+          <a:xfrm>
+            <a:off x="0" y="1234440"/>
+            <a:ext cx="12188952" cy="12700"/>
+          </a:xfrm>
+          <a:prstGeom prst="rect">
+            <a:avLst/>
+          </a:prstGeom>
+          <a:solidFill>
+            <a:srgbClr val="D8DFE4"/>
+          </a:solidFill>
+          <a:ln>
+            <a:noFill/>
+          </a:ln>
+        </p:spPr>
+        <p:style>
+          <a:lnRef idx="1">
+            <a:schemeClr val="accent1"/>
+          </a:lnRef>
+          <a:fillRef idx="3">
+            <a:schemeClr val="accent1"/>
+          </a:fillRef>
+          <a:effectRef idx="2">
+            <a:schemeClr val="accent1"/>
+          </a:effectRef>
+          <a:fontRef idx="minor">
+            <a:schemeClr val="lt1"/>
+          </a:fontRef>
+        </p:style>
+        <p:txBody>
+          <a:bodyPr rtlCol="0" anchor="ctr"/>
+          <a:lstStyle/>
+          <a:p>
+            <a:pPr algn="ctr"/>
+          </a:p>
+        </p:txBody>
+      </p:sp>
+      <p:sp>
+        <p:nvSpPr>
+          <p:cNvPr id="6" name="Rectangle 5"/>
+          <p:cNvSpPr/>
+          <p:nvPr/>
+        </p:nvSpPr>
+        <p:spPr>
+          <a:xfrm>
+            <a:off x="685800" y="502920"/>
+            <a:ext cx="36576" cy="658368"/>
+          </a:xfrm>
+          <a:prstGeom prst="rect">
+            <a:avLst/>
+          </a:prstGeom>
+          <a:solidFill>
+            <a:srgbClr val="D9C089"/>
+          </a:solidFill>
+          <a:ln>
+            <a:noFill/>
+          </a:ln>
+        </p:spPr>
+        <p:style>
+          <a:lnRef idx="1">
+            <a:schemeClr val="accent1"/>
+          </a:lnRef>
+          <a:fillRef idx="3">
+            <a:schemeClr val="accent1"/>
+          </a:fillRef>
+          <a:effectRef idx="2">
+            <a:schemeClr val="accent1"/>
+          </a:effectRef>
+          <a:fontRef idx="minor">
+            <a:schemeClr val="lt1"/>
+          </a:fontRef>
+        </p:style>
+        <p:txBody>
+          <a:bodyPr rtlCol="0" anchor="ctr"/>
+          <a:lstStyle/>
+          <a:p>
+            <a:pPr algn="ctr"/>
+          </a:p>
+        </p:txBody>
+      </p:sp>
+      <p:sp>
+        <p:nvSpPr>
+          <p:cNvPr id="7" name="TextBox 6"/>
+          <p:cNvSpPr txBox="1"/>
+          <p:nvPr/>
+        </p:nvSpPr>
+        <p:spPr>
+          <a:xfrm>
+            <a:off x="813816" y="502920"/>
+            <a:ext cx="10634472" cy="685800"/>
+          </a:xfrm>
+          <a:prstGeom prst="rect">
+            <a:avLst/>
+          </a:prstGeom>
+          <a:noFill/>
+        </p:spPr>
+        <p:txBody>
+          <a:bodyPr wrap="square">
+            <a:spAutoFit/>
+          </a:bodyPr>
+          <a:lstStyle/>
+          <a:p>
+            <a:pPr algn="l"/>
+            <a:r>
+              <a:rPr sz="2400" b="1" i="0">
+                <a:solidFill>
+                  <a:srgbClr val="1F2C56"/>
+                </a:solidFill>
+                <a:latin typeface="Arial"/>
+              </a:rPr>
+              <a:t>Reflexion und Selbstcheck</a:t>
+            </a:r>
+          </a:p>
+        </p:txBody>
+      </p:sp>
+      <p:sp>
+        <p:nvSpPr>
+          <p:cNvPr id="8" name="TextBox 7"/>
+          <p:cNvSpPr txBox="1"/>
+          <p:nvPr/>
+        </p:nvSpPr>
+        <p:spPr>
+          <a:xfrm>
+            <a:off x="685800" y="1417320"/>
+            <a:ext cx="10817352" cy="4892040"/>
+          </a:xfrm>
+          <a:prstGeom prst="rect">
+            <a:avLst/>
+          </a:prstGeom>
+          <a:noFill/>
+        </p:spPr>
+        <p:txBody>
+          <a:bodyPr wrap="square" anchor="ctr">
+            <a:spAutoFit/>
+          </a:bodyPr>
+          <a:lstStyle/>
           <a:p>
             <a:pPr marL="190500" indent="-190500">
               <a:spcBef>
@@ -5964,13 +6357,13 @@
               </a:spcAft>
             </a:pPr>
             <a:r>
-              <a:rPr sz="1400">
+              <a:rPr sz="1300">
                 <a:solidFill>
                   <a:srgbClr val="3D5466"/>
                 </a:solidFill>
                 <a:latin typeface="Arial"/>
               </a:rPr>
-              <a:t>▸  Finanzkennzahlen (letzte 3 Perioden):</a:t>
+              <a:t>▸  Bei welchem Kunden ignorieren Sie gerade ein schwaches Signal, weil die Zahlen noch stimmen?</a:t>
             </a:r>
           </a:p>
           <a:p>
@@ -5983,13 +6376,13 @@
               </a:spcAft>
             </a:pPr>
             <a:r>
-              <a:rPr sz="1400">
+              <a:rPr sz="1300">
                 <a:solidFill>
                   <a:srgbClr val="3D5466"/>
                 </a:solidFill>
                 <a:latin typeface="Arial"/>
               </a:rPr>
-              <a:t>▸  Zusatzinformationen aus dem letzten Gespräch (vor 6 Wochen):</a:t>
+              <a:t>▸  Welchen qualitativen Frühindikator übersehen Sie im Alltag am ehesten?</a:t>
             </a:r>
           </a:p>
           <a:p>
@@ -6002,32 +6395,13 @@
               </a:spcAft>
             </a:pPr>
             <a:r>
-              <a:rPr sz="1400">
+              <a:rPr sz="1300">
                 <a:solidFill>
                   <a:srgbClr val="3D5466"/>
                 </a:solidFill>
                 <a:latin typeface="Arial"/>
               </a:rPr>
-              <a:t>▸  Ampel-Checkliste ausfüllen</a:t>
-            </a:r>
-          </a:p>
-          <a:p>
-            <a:pPr marL="190500" indent="-190500">
-              <a:spcBef>
-                <a:spcPts val="400"/>
-              </a:spcBef>
-              <a:spcAft>
-                <a:spcPts val="200"/>
-              </a:spcAft>
-            </a:pPr>
-            <a:r>
-              <a:rPr sz="1400">
-                <a:solidFill>
-                  <a:srgbClr val="3D5466"/>
-                </a:solidFill>
-                <a:latin typeface="Arial"/>
-              </a:rPr>
-              <a:t>▸  Füllen Sie die Ampel-Checkliste für die Renner Metallverarbeitung GmbH (Berichtsjahr aktuell) vollständig aus.</a:t>
+              <a:t>▸  Kennen Sie Ihren Eskalationspfad für die rote Ampel – auswendig?</a:t>
             </a:r>
           </a:p>
         </p:txBody>
@@ -6035,84 +6409,6 @@
       <p:sp>
         <p:nvSpPr>
           <p:cNvPr id="9" name="Rectangle 8"/>
-          <p:cNvSpPr/>
-          <p:nvPr/>
-        </p:nvSpPr>
-        <p:spPr>
-          <a:xfrm>
-            <a:off x="685800" y="5486400"/>
-            <a:ext cx="10817352" cy="640080"/>
-          </a:xfrm>
-          <a:prstGeom prst="rect">
-            <a:avLst/>
-          </a:prstGeom>
-          <a:solidFill>
-            <a:srgbClr val="1F2C56"/>
-          </a:solidFill>
-          <a:ln>
-            <a:noFill/>
-          </a:ln>
-        </p:spPr>
-        <p:style>
-          <a:lnRef idx="1">
-            <a:schemeClr val="accent1"/>
-          </a:lnRef>
-          <a:fillRef idx="3">
-            <a:schemeClr val="accent1"/>
-          </a:fillRef>
-          <a:effectRef idx="2">
-            <a:schemeClr val="accent1"/>
-          </a:effectRef>
-          <a:fontRef idx="minor">
-            <a:schemeClr val="lt1"/>
-          </a:fontRef>
-        </p:style>
-        <p:txBody>
-          <a:bodyPr rtlCol="0" anchor="ctr"/>
-          <a:lstStyle/>
-          <a:p>
-            <a:pPr algn="ctr"/>
-          </a:p>
-        </p:txBody>
-      </p:sp>
-      <p:sp>
-        <p:nvSpPr>
-          <p:cNvPr id="10" name="TextBox 9"/>
-          <p:cNvSpPr txBox="1"/>
-          <p:nvPr/>
-        </p:nvSpPr>
-        <p:spPr>
-          <a:xfrm>
-            <a:off x="868680" y="5596128"/>
-            <a:ext cx="10451592" cy="457200"/>
-          </a:xfrm>
-          <a:prstGeom prst="rect">
-            <a:avLst/>
-          </a:prstGeom>
-          <a:noFill/>
-        </p:spPr>
-        <p:txBody>
-          <a:bodyPr wrap="square">
-            <a:spAutoFit/>
-          </a:bodyPr>
-          <a:lstStyle/>
-          <a:p>
-            <a:pPr algn="l"/>
-            <a:r>
-              <a:rPr sz="1300" b="1" i="0">
-                <a:solidFill>
-                  <a:srgbClr val="FFFFFF"/>
-                </a:solidFill>
-                <a:latin typeface="Arial"/>
-              </a:rPr>
-              <a:t>→  Bearbeitung im Teilnehmer-Workbook (Arbeitsblatt mit Ausfüllfeldern)</a:t>
-            </a:r>
-          </a:p>
-        </p:txBody>
-      </p:sp>
-      <p:sp>
-        <p:nvSpPr>
-          <p:cNvPr id="11" name="Rectangle 10"/>
           <p:cNvSpPr/>
           <p:nvPr/>
         </p:nvSpPr>
@@ -6155,7 +6451,7 @@
       </p:sp>
       <p:sp>
         <p:nvSpPr>
-          <p:cNvPr id="12" name="TextBox 11"/>
+          <p:cNvPr id="10" name="TextBox 9"/>
           <p:cNvSpPr txBox="1"/>
           <p:nvPr/>
         </p:nvSpPr>
@@ -7817,7 +8113,7 @@
                 </a:solidFill>
                 <a:latin typeface="Arial"/>
               </a:rPr>
-              <a:t>Kreditrisiko – Grundbegriffe und Bedeutung für den Berater</a:t>
+              <a:t>Das erste Warnsignal steht selten in der Bilanz</a:t>
             </a:r>
           </a:p>
         </p:txBody>
@@ -7843,6 +8139,25 @@
             <a:spAutoFit/>
           </a:bodyPr>
           <a:lstStyle/>
+          <a:p>
+            <a:pPr marL="177800" indent="-177800">
+              <a:spcBef>
+                <a:spcPts val="600"/>
+              </a:spcBef>
+              <a:spcAft>
+                <a:spcPts val="200"/>
+              </a:spcAft>
+            </a:pPr>
+            <a:r>
+              <a:rPr sz="1200" i="1">
+                <a:solidFill>
+                  <a:srgbClr val="3D5466"/>
+                </a:solidFill>
+                <a:latin typeface="Arial"/>
+              </a:rPr>
+              <a:t>→  Das erste Warnsignal steht selten in der Bilanz – meist im Kontokorrent.</a:t>
+            </a:r>
+          </a:p>
           <a:p>
             <a:pPr marL="190500" indent="-190500">
               <a:spcBef>
@@ -7859,7 +8174,26 @@
                 </a:solidFill>
                 <a:latin typeface="Arial"/>
               </a:rPr>
-              <a:t>▸  Die drei Kreditrisikoarten:</a:t>
+              <a:t>▸  Qualitative Frühindikatoren laufen den Kennzahlen voraus.</a:t>
+            </a:r>
+          </a:p>
+          <a:p>
+            <a:pPr marL="190500" indent="-190500">
+              <a:spcBef>
+                <a:spcPts val="400"/>
+              </a:spcBef>
+              <a:spcAft>
+                <a:spcPts val="200"/>
+              </a:spcAft>
+            </a:pPr>
+            <a:r>
+              <a:rPr sz="1300">
+                <a:solidFill>
+                  <a:srgbClr val="3D5466"/>
+                </a:solidFill>
+                <a:latin typeface="Arial"/>
+              </a:rPr>
+              <a:t>▸  Wer auf das schwache Signal reagiert, verhindert den Schaden, statt ihn zu verwalten.</a:t>
             </a:r>
           </a:p>
         </p:txBody>
@@ -8197,7 +8531,7 @@
                 </a:solidFill>
                 <a:latin typeface="Arial"/>
               </a:rPr>
-              <a:t>Die vier Krisenphasen [Q-099]</a:t>
+              <a:t>Die vier Krisenphasen: je früher, desto mehr Spielraum</a:t>
             </a:r>
           </a:p>
         </p:txBody>
@@ -8223,6 +8557,25 @@
             <a:spAutoFit/>
           </a:bodyPr>
           <a:lstStyle/>
+          <a:p>
+            <a:pPr marL="177800" indent="-177800">
+              <a:spcBef>
+                <a:spcPts val="600"/>
+              </a:spcBef>
+              <a:spcAft>
+                <a:spcPts val="200"/>
+              </a:spcAft>
+            </a:pPr>
+            <a:r>
+              <a:rPr sz="1200" i="1">
+                <a:solidFill>
+                  <a:srgbClr val="3D5466"/>
+                </a:solidFill>
+                <a:latin typeface="Arial"/>
+              </a:rPr>
+              <a:t>→  Eine Unternehmenskrise läuft in Phasen ab – der Handlungsspielraum ist am Anfang am größten und schwindet mit jeder Phase.</a:t>
+            </a:r>
+          </a:p>
           <a:p>
             <a:pPr marL="190500" indent="-190500">
               <a:spcBef>
@@ -8239,26 +8592,26 @@
                 </a:solidFill>
                 <a:latin typeface="Arial"/>
               </a:rPr>
-              <a:t>▸  Nicht jede rote Ampel hat dieselbe Dringlichkeit. Das Krisenphasen-Modell hilft einzuordnen, wie weit ein Unternehmen bereits in die Krise gerutscht ist:</a:t>
-            </a:r>
-          </a:p>
-          <a:p>
-            <a:pPr marL="177800" indent="-177800">
+              <a:t>▸  Strategiekrise, Ertragskrise, Liquiditätskrise, Insolvenz.</a:t>
+            </a:r>
+          </a:p>
+          <a:p>
+            <a:pPr marL="190500" indent="-190500">
               <a:spcBef>
-                <a:spcPts val="600"/>
+                <a:spcPts val="400"/>
               </a:spcBef>
               <a:spcAft>
                 <a:spcPts val="200"/>
               </a:spcAft>
             </a:pPr>
             <a:r>
-              <a:rPr sz="1200" i="1">
+              <a:rPr sz="1300">
                 <a:solidFill>
                   <a:srgbClr val="3D5466"/>
                 </a:solidFill>
                 <a:latin typeface="Arial"/>
               </a:rPr>
-              <a:t>→  Merksatz: Die Ampel-Checkliste zeigt, wo das Signal liegt. Die Krisenphase zeigt, wie dringend gehandelt werden muss.</a:t>
+              <a:t>▸  Jede Phase hat eigene Frühwarnindikatoren – und einen eigenen Eskalationspfad.</a:t>
             </a:r>
           </a:p>
         </p:txBody>
@@ -8596,7 +8949,7 @@
                 </a:solidFill>
                 <a:latin typeface="Arial"/>
               </a:rPr>
-              <a:t>Frühwarnindikatoren – Quantitativ und Qualitativ</a:t>
+              <a:t>Frühwarnindikatoren: quantitativ und qualitativ</a:t>
             </a:r>
           </a:p>
         </p:txBody>
@@ -8622,6 +8975,25 @@
             <a:spAutoFit/>
           </a:bodyPr>
           <a:lstStyle/>
+          <a:p>
+            <a:pPr marL="177800" indent="-177800">
+              <a:spcBef>
+                <a:spcPts val="600"/>
+              </a:spcBef>
+              <a:spcAft>
+                <a:spcPts val="200"/>
+              </a:spcAft>
+            </a:pPr>
+            <a:r>
+              <a:rPr sz="1200" i="1">
+                <a:solidFill>
+                  <a:srgbClr val="3D5466"/>
+                </a:solidFill>
+                <a:latin typeface="Arial"/>
+              </a:rPr>
+              <a:t>→  Die härtesten Frühsignale sind oft weich – Verhalten, Kommunikation, Kontobewegungen, nicht die Jahresbilanz.</a:t>
+            </a:r>
+          </a:p>
           <a:p>
             <a:pPr marL="190500" indent="-190500">
               <a:spcBef>
@@ -8638,7 +9010,7 @@
                 </a:solidFill>
                 <a:latin typeface="Arial"/>
               </a:rPr>
-              <a:t>▸  Frühwarnindikatoren lassen sich in zwei komplementäre Kategorien einteilen :</a:t>
+              <a:t>▸  Quantitativ: Kontokorrent-Auslastung, Zinsverzug, rückläufige Umsätze, Ratingverschlechterung.</a:t>
             </a:r>
           </a:p>
           <a:p>
@@ -8657,64 +9029,7 @@
                 </a:solidFill>
                 <a:latin typeface="Arial"/>
               </a:rPr>
-              <a:t>▸  Quantitative Indikatoren (aus Jahresabschluss und BWA):</a:t>
-            </a:r>
-          </a:p>
-          <a:p>
-            <a:pPr marL="190500" indent="-190500">
-              <a:spcBef>
-                <a:spcPts val="400"/>
-              </a:spcBef>
-              <a:spcAft>
-                <a:spcPts val="200"/>
-              </a:spcAft>
-            </a:pPr>
-            <a:r>
-              <a:rPr sz="1300">
-                <a:solidFill>
-                  <a:srgbClr val="3D5466"/>
-                </a:solidFill>
-                <a:latin typeface="Arial"/>
-              </a:rPr>
-              <a:t>▸  NFK = verzinsliches Fremdkapital abzüglich liquide Mittel</a:t>
-            </a:r>
-          </a:p>
-          <a:p>
-            <a:pPr marL="190500" indent="-190500">
-              <a:spcBef>
-                <a:spcPts val="400"/>
-              </a:spcBef>
-              <a:spcAft>
-                <a:spcPts val="200"/>
-              </a:spcAft>
-            </a:pPr>
-            <a:r>
-              <a:rPr sz="1300">
-                <a:solidFill>
-                  <a:srgbClr val="3D5466"/>
-                </a:solidFill>
-                <a:latin typeface="Arial"/>
-              </a:rPr>
-              <a:t>▸  Qualitative Indikatoren (aus Kundengespräch und Marktbeobachtung):</a:t>
-            </a:r>
-          </a:p>
-          <a:p>
-            <a:pPr marL="177800" indent="-177800">
-              <a:spcBef>
-                <a:spcPts val="600"/>
-              </a:spcBef>
-              <a:spcAft>
-                <a:spcPts val="200"/>
-              </a:spcAft>
-            </a:pPr>
-            <a:r>
-              <a:rPr sz="1200" i="1">
-                <a:solidFill>
-                  <a:srgbClr val="3D5466"/>
-                </a:solidFill>
-                <a:latin typeface="Arial"/>
-              </a:rPr>
-              <a:t>→  Merksatz: Qualitative Signale gehen quantitativen häufig 6–12 Monate voraus . Wer nur auf Zahlen wartet, reagiert zu spät.</a:t>
+              <a:t>▸  Qualitativ: verzögerte Unterlagen, Führungswechsel, Auftragsstornos, Gesprächsvermeidung.</a:t>
             </a:r>
           </a:p>
         </p:txBody>
@@ -8931,7 +9246,7 @@
                 </a:solidFill>
                 <a:latin typeface="Consolas"/>
               </a:rPr>
-              <a:t>M04  ·  ÜBERSICHT</a:t>
+              <a:t>M04  ·  SCHAUBILD</a:t>
             </a:r>
           </a:p>
         </p:txBody>
@@ -8966,7 +9281,7 @@
                 </a:solidFill>
                 <a:latin typeface="Arial"/>
               </a:rPr>
-              <a:t>Frühwarnindikatoren – Quantitativ und Qualitativ</a:t>
+              <a:t>Die Frühwarn-Ampelkarte</a:t>
             </a:r>
           </a:p>
         </p:txBody>
@@ -9014,607 +9329,30 @@
           </a:p>
         </p:txBody>
       </p:sp>
-      <p:graphicFrame>
-        <p:nvGraphicFramePr>
-          <p:cNvPr id="7" name="Table 6"/>
-          <p:cNvGraphicFramePr>
-            <a:graphicFrameLocks noGrp="1"/>
-          </p:cNvGraphicFramePr>
-          <p:nvPr/>
-        </p:nvGraphicFramePr>
-        <p:xfrm>
-          <a:off x="685800" y="1417320"/>
-          <a:ext cx="10817352" cy="2304288"/>
-        </p:xfrm>
-        <a:graphic>
-          <a:graphicData uri="http://schemas.openxmlformats.org/drawingml/2006/table">
-            <a:tbl>
-              <a:tblPr firstRow="1" bandRow="1">
-                <a:tableStyleId>{5C22544A-7EE6-4342-B048-85BDC9FD1C3A}</a:tableStyleId>
-              </a:tblPr>
-              <a:tblGrid>
-                <a:gridCol w="2163470"/>
-                <a:gridCol w="2163470"/>
-                <a:gridCol w="2163470"/>
-                <a:gridCol w="2163470"/>
-                <a:gridCol w="2163472"/>
-              </a:tblGrid>
-              <a:tr h="384048">
-                <a:tc>
-                  <a:txBody>
-                    <a:bodyPr/>
-                    <a:lstStyle/>
-                    <a:p>
-                      <a:r>
-                        <a:rPr sz="1100" b="1">
-                          <a:solidFill>
-                            <a:srgbClr val="FFFFFF"/>
-                          </a:solidFill>
-                          <a:latin typeface="Arial"/>
-                        </a:rPr>
-                        <a:t>Indikator</a:t>
-                      </a:r>
-                    </a:p>
-                  </a:txBody>
-                  <a:tcPr>
-                    <a:solidFill>
-                      <a:srgbClr val="1F2C56"/>
-                    </a:solidFill>
-                  </a:tcPr>
-                </a:tc>
-                <a:tc>
-                  <a:txBody>
-                    <a:bodyPr/>
-                    <a:lstStyle/>
-                    <a:p>
-                      <a:r>
-                        <a:rPr sz="1100" b="1">
-                          <a:solidFill>
-                            <a:srgbClr val="FFFFFF"/>
-                          </a:solidFill>
-                          <a:latin typeface="Arial"/>
-                        </a:rPr>
-                        <a:t>Formel</a:t>
-                      </a:r>
-                    </a:p>
-                  </a:txBody>
-                  <a:tcPr>
-                    <a:solidFill>
-                      <a:srgbClr val="1F2C56"/>
-                    </a:solidFill>
-                  </a:tcPr>
-                </a:tc>
-                <a:tc>
-                  <a:txBody>
-                    <a:bodyPr/>
-                    <a:lstStyle/>
-                    <a:p>
-                      <a:r>
-                        <a:rPr sz="1100" b="1">
-                          <a:solidFill>
-                            <a:srgbClr val="FFFFFF"/>
-                          </a:solidFill>
-                          <a:latin typeface="Arial"/>
-                        </a:rPr>
-                        <a:t>Grün</a:t>
-                      </a:r>
-                    </a:p>
-                  </a:txBody>
-                  <a:tcPr>
-                    <a:solidFill>
-                      <a:srgbClr val="1F2C56"/>
-                    </a:solidFill>
-                  </a:tcPr>
-                </a:tc>
-                <a:tc>
-                  <a:txBody>
-                    <a:bodyPr/>
-                    <a:lstStyle/>
-                    <a:p>
-                      <a:r>
-                        <a:rPr sz="1100" b="1">
-                          <a:solidFill>
-                            <a:srgbClr val="FFFFFF"/>
-                          </a:solidFill>
-                          <a:latin typeface="Arial"/>
-                        </a:rPr>
-                        <a:t>Gelb</a:t>
-                      </a:r>
-                    </a:p>
-                  </a:txBody>
-                  <a:tcPr>
-                    <a:solidFill>
-                      <a:srgbClr val="1F2C56"/>
-                    </a:solidFill>
-                  </a:tcPr>
-                </a:tc>
-                <a:tc>
-                  <a:txBody>
-                    <a:bodyPr/>
-                    <a:lstStyle/>
-                    <a:p>
-                      <a:r>
-                        <a:rPr sz="1100" b="1">
-                          <a:solidFill>
-                            <a:srgbClr val="FFFFFF"/>
-                          </a:solidFill>
-                          <a:latin typeface="Arial"/>
-                        </a:rPr>
-                        <a:t>Rot</a:t>
-                      </a:r>
-                    </a:p>
-                  </a:txBody>
-                  <a:tcPr>
-                    <a:solidFill>
-                      <a:srgbClr val="1F2C56"/>
-                    </a:solidFill>
-                  </a:tcPr>
-                </a:tc>
-              </a:tr>
-              <a:tr h="384048">
-                <a:tc>
-                  <a:txBody>
-                    <a:bodyPr/>
-                    <a:lstStyle/>
-                    <a:p>
-                      <a:r>
-                        <a:rPr sz="1050">
-                          <a:solidFill>
-                            <a:srgbClr val="3D5466"/>
-                          </a:solidFill>
-                          <a:latin typeface="Arial"/>
-                        </a:rPr>
-                        <a:t>EBITDA-Marge</a:t>
-                      </a:r>
-                    </a:p>
-                  </a:txBody>
-                  <a:tcPr/>
-                </a:tc>
-                <a:tc>
-                  <a:txBody>
-                    <a:bodyPr/>
-                    <a:lstStyle/>
-                    <a:p>
-                      <a:r>
-                        <a:rPr sz="1050">
-                          <a:solidFill>
-                            <a:srgbClr val="3D5466"/>
-                          </a:solidFill>
-                          <a:latin typeface="Arial"/>
-                        </a:rPr>
-                        <a:t>EBITDA / Umsatz × 100</a:t>
-                      </a:r>
-                    </a:p>
-                  </a:txBody>
-                  <a:tcPr/>
-                </a:tc>
-                <a:tc>
-                  <a:txBody>
-                    <a:bodyPr/>
-                    <a:lstStyle/>
-                    <a:p>
-                      <a:r>
-                        <a:rPr sz="1050">
-                          <a:solidFill>
-                            <a:srgbClr val="3D5466"/>
-                          </a:solidFill>
-                          <a:latin typeface="Arial"/>
-                        </a:rPr>
-                        <a:t>&gt; 8 %</a:t>
-                      </a:r>
-                    </a:p>
-                  </a:txBody>
-                  <a:tcPr/>
-                </a:tc>
-                <a:tc>
-                  <a:txBody>
-                    <a:bodyPr/>
-                    <a:lstStyle/>
-                    <a:p>
-                      <a:r>
-                        <a:rPr sz="1050">
-                          <a:solidFill>
-                            <a:srgbClr val="3D5466"/>
-                          </a:solidFill>
-                          <a:latin typeface="Arial"/>
-                        </a:rPr>
-                        <a:t>5–8 %</a:t>
-                      </a:r>
-                    </a:p>
-                  </a:txBody>
-                  <a:tcPr/>
-                </a:tc>
-                <a:tc>
-                  <a:txBody>
-                    <a:bodyPr/>
-                    <a:lstStyle/>
-                    <a:p>
-                      <a:r>
-                        <a:rPr sz="1050">
-                          <a:solidFill>
-                            <a:srgbClr val="3D5466"/>
-                          </a:solidFill>
-                          <a:latin typeface="Arial"/>
-                        </a:rPr>
-                        <a:t>&lt; 5 %</a:t>
-                      </a:r>
-                    </a:p>
-                  </a:txBody>
-                  <a:tcPr/>
-                </a:tc>
-              </a:tr>
-              <a:tr h="384048">
-                <a:tc>
-                  <a:txBody>
-                    <a:bodyPr/>
-                    <a:lstStyle/>
-                    <a:p>
-                      <a:r>
-                        <a:rPr sz="1050">
-                          <a:solidFill>
-                            <a:srgbClr val="3D5466"/>
-                          </a:solidFill>
-                          <a:latin typeface="Arial"/>
-                        </a:rPr>
-                        <a:t>Leverage (NFK/EBITDA)</a:t>
-                      </a:r>
-                    </a:p>
-                  </a:txBody>
-                  <a:tcPr/>
-                </a:tc>
-                <a:tc>
-                  <a:txBody>
-                    <a:bodyPr/>
-                    <a:lstStyle/>
-                    <a:p>
-                      <a:r>
-                        <a:rPr sz="1050">
-                          <a:solidFill>
-                            <a:srgbClr val="3D5466"/>
-                          </a:solidFill>
-                          <a:latin typeface="Arial"/>
-                        </a:rPr>
-                        <a:t>Netto-Finanzverbindlichkeiten / EBITDA</a:t>
-                      </a:r>
-                    </a:p>
-                  </a:txBody>
-                  <a:tcPr/>
-                </a:tc>
-                <a:tc>
-                  <a:txBody>
-                    <a:bodyPr/>
-                    <a:lstStyle/>
-                    <a:p>
-                      <a:r>
-                        <a:rPr sz="1050">
-                          <a:solidFill>
-                            <a:srgbClr val="3D5466"/>
-                          </a:solidFill>
-                          <a:latin typeface="Arial"/>
-                        </a:rPr>
-                        <a:t>&lt; 3,0x</a:t>
-                      </a:r>
-                    </a:p>
-                  </a:txBody>
-                  <a:tcPr/>
-                </a:tc>
-                <a:tc>
-                  <a:txBody>
-                    <a:bodyPr/>
-                    <a:lstStyle/>
-                    <a:p>
-                      <a:r>
-                        <a:rPr sz="1050">
-                          <a:solidFill>
-                            <a:srgbClr val="3D5466"/>
-                          </a:solidFill>
-                          <a:latin typeface="Arial"/>
-                        </a:rPr>
-                        <a:t>3,0–4,0x</a:t>
-                      </a:r>
-                    </a:p>
-                  </a:txBody>
-                  <a:tcPr/>
-                </a:tc>
-                <a:tc>
-                  <a:txBody>
-                    <a:bodyPr/>
-                    <a:lstStyle/>
-                    <a:p>
-                      <a:r>
-                        <a:rPr sz="1050">
-                          <a:solidFill>
-                            <a:srgbClr val="3D5466"/>
-                          </a:solidFill>
-                          <a:latin typeface="Arial"/>
-                        </a:rPr>
-                        <a:t>&gt; 4,0x</a:t>
-                      </a:r>
-                    </a:p>
-                  </a:txBody>
-                  <a:tcPr/>
-                </a:tc>
-              </a:tr>
-              <a:tr h="384048">
-                <a:tc>
-                  <a:txBody>
-                    <a:bodyPr/>
-                    <a:lstStyle/>
-                    <a:p>
-                      <a:r>
-                        <a:rPr sz="1050">
-                          <a:solidFill>
-                            <a:srgbClr val="3D5466"/>
-                          </a:solidFill>
-                          <a:latin typeface="Arial"/>
-                        </a:rPr>
-                        <a:t>Eigenkapitalquote</a:t>
-                      </a:r>
-                    </a:p>
-                  </a:txBody>
-                  <a:tcPr/>
-                </a:tc>
-                <a:tc>
-                  <a:txBody>
-                    <a:bodyPr/>
-                    <a:lstStyle/>
-                    <a:p>
-                      <a:r>
-                        <a:rPr sz="1050">
-                          <a:solidFill>
-                            <a:srgbClr val="3D5466"/>
-                          </a:solidFill>
-                          <a:latin typeface="Arial"/>
-                        </a:rPr>
-                        <a:t>EK / Bilanzsumme × 100</a:t>
-                      </a:r>
-                    </a:p>
-                  </a:txBody>
-                  <a:tcPr/>
-                </a:tc>
-                <a:tc>
-                  <a:txBody>
-                    <a:bodyPr/>
-                    <a:lstStyle/>
-                    <a:p>
-                      <a:r>
-                        <a:rPr sz="1050">
-                          <a:solidFill>
-                            <a:srgbClr val="3D5466"/>
-                          </a:solidFill>
-                          <a:latin typeface="Arial"/>
-                        </a:rPr>
-                        <a:t>&gt; 20 %</a:t>
-                      </a:r>
-                    </a:p>
-                  </a:txBody>
-                  <a:tcPr/>
-                </a:tc>
-                <a:tc>
-                  <a:txBody>
-                    <a:bodyPr/>
-                    <a:lstStyle/>
-                    <a:p>
-                      <a:r>
-                        <a:rPr sz="1050">
-                          <a:solidFill>
-                            <a:srgbClr val="3D5466"/>
-                          </a:solidFill>
-                          <a:latin typeface="Arial"/>
-                        </a:rPr>
-                        <a:t>10–20 %</a:t>
-                      </a:r>
-                    </a:p>
-                  </a:txBody>
-                  <a:tcPr/>
-                </a:tc>
-                <a:tc>
-                  <a:txBody>
-                    <a:bodyPr/>
-                    <a:lstStyle/>
-                    <a:p>
-                      <a:r>
-                        <a:rPr sz="1050">
-                          <a:solidFill>
-                            <a:srgbClr val="3D5466"/>
-                          </a:solidFill>
-                          <a:latin typeface="Arial"/>
-                        </a:rPr>
-                        <a:t>&lt; 10 %</a:t>
-                      </a:r>
-                    </a:p>
-                  </a:txBody>
-                  <a:tcPr/>
-                </a:tc>
-              </a:tr>
-              <a:tr h="384048">
-                <a:tc>
-                  <a:txBody>
-                    <a:bodyPr/>
-                    <a:lstStyle/>
-                    <a:p>
-                      <a:r>
-                        <a:rPr sz="1050">
-                          <a:solidFill>
-                            <a:srgbClr val="3D5466"/>
-                          </a:solidFill>
-                          <a:latin typeface="Arial"/>
-                        </a:rPr>
-                        <a:t>KK-Inanspruchnahme (Ø)</a:t>
-                      </a:r>
-                    </a:p>
-                  </a:txBody>
-                  <a:tcPr/>
-                </a:tc>
-                <a:tc>
-                  <a:txBody>
-                    <a:bodyPr/>
-                    <a:lstStyle/>
-                    <a:p>
-                      <a:r>
-                        <a:rPr sz="1050">
-                          <a:solidFill>
-                            <a:srgbClr val="3D5466"/>
-                          </a:solidFill>
-                          <a:latin typeface="Arial"/>
-                        </a:rPr>
-                        <a:t>Ø-Inanspruchnahme / Limit × 100</a:t>
-                      </a:r>
-                    </a:p>
-                  </a:txBody>
-                  <a:tcPr/>
-                </a:tc>
-                <a:tc>
-                  <a:txBody>
-                    <a:bodyPr/>
-                    <a:lstStyle/>
-                    <a:p>
-                      <a:r>
-                        <a:rPr sz="1050">
-                          <a:solidFill>
-                            <a:srgbClr val="3D5466"/>
-                          </a:solidFill>
-                          <a:latin typeface="Arial"/>
-                        </a:rPr>
-                        <a:t>&lt; 60 %</a:t>
-                      </a:r>
-                    </a:p>
-                  </a:txBody>
-                  <a:tcPr/>
-                </a:tc>
-                <a:tc>
-                  <a:txBody>
-                    <a:bodyPr/>
-                    <a:lstStyle/>
-                    <a:p>
-                      <a:r>
-                        <a:rPr sz="1050">
-                          <a:solidFill>
-                            <a:srgbClr val="3D5466"/>
-                          </a:solidFill>
-                          <a:latin typeface="Arial"/>
-                        </a:rPr>
-                        <a:t>60–85 %</a:t>
-                      </a:r>
-                    </a:p>
-                  </a:txBody>
-                  <a:tcPr/>
-                </a:tc>
-                <a:tc>
-                  <a:txBody>
-                    <a:bodyPr/>
-                    <a:lstStyle/>
-                    <a:p>
-                      <a:r>
-                        <a:rPr sz="1050">
-                          <a:solidFill>
-                            <a:srgbClr val="3D5466"/>
-                          </a:solidFill>
-                          <a:latin typeface="Arial"/>
-                        </a:rPr>
-                        <a:t>&gt; 85 %</a:t>
-                      </a:r>
-                    </a:p>
-                  </a:txBody>
-                  <a:tcPr/>
-                </a:tc>
-              </a:tr>
-              <a:tr h="384048">
-                <a:tc>
-                  <a:txBody>
-                    <a:bodyPr/>
-                    <a:lstStyle/>
-                    <a:p>
-                      <a:r>
-                        <a:rPr sz="1050">
-                          <a:solidFill>
-                            <a:srgbClr val="3D5466"/>
-                          </a:solidFill>
-                          <a:latin typeface="Arial"/>
-                        </a:rPr>
-                        <a:t>Jahresabschluss-Vorlage</a:t>
-                      </a:r>
-                    </a:p>
-                  </a:txBody>
-                  <a:tcPr/>
-                </a:tc>
-                <a:tc>
-                  <a:txBody>
-                    <a:bodyPr/>
-                    <a:lstStyle/>
-                    <a:p>
-                      <a:r>
-                        <a:rPr sz="1050">
-                          <a:solidFill>
-                            <a:srgbClr val="3D5466"/>
-                          </a:solidFill>
-                          <a:latin typeface="Arial"/>
-                        </a:rPr>
-                        <a:t>Monate nach Geschäftsjahresende</a:t>
-                      </a:r>
-                    </a:p>
-                  </a:txBody>
-                  <a:tcPr/>
-                </a:tc>
-                <a:tc>
-                  <a:txBody>
-                    <a:bodyPr/>
-                    <a:lstStyle/>
-                    <a:p>
-                      <a:r>
-                        <a:rPr sz="1050">
-                          <a:solidFill>
-                            <a:srgbClr val="3D5466"/>
-                          </a:solidFill>
-                          <a:latin typeface="Arial"/>
-                        </a:rPr>
-                        <a:t>&lt; 6</a:t>
-                      </a:r>
-                    </a:p>
-                  </a:txBody>
-                  <a:tcPr/>
-                </a:tc>
-                <a:tc>
-                  <a:txBody>
-                    <a:bodyPr/>
-                    <a:lstStyle/>
-                    <a:p>
-                      <a:r>
-                        <a:rPr sz="1050">
-                          <a:solidFill>
-                            <a:srgbClr val="3D5466"/>
-                          </a:solidFill>
-                          <a:latin typeface="Arial"/>
-                        </a:rPr>
-                        <a:t>6–9</a:t>
-                      </a:r>
-                    </a:p>
-                  </a:txBody>
-                  <a:tcPr/>
-                </a:tc>
-                <a:tc>
-                  <a:txBody>
-                    <a:bodyPr/>
-                    <a:lstStyle/>
-                    <a:p>
-                      <a:r>
-                        <a:rPr sz="1050">
-                          <a:solidFill>
-                            <a:srgbClr val="3D5466"/>
-                          </a:solidFill>
-                          <a:latin typeface="Arial"/>
-                        </a:rPr>
-                        <a:t>&gt; 9 / Verweigerung</a:t>
-                      </a:r>
-                    </a:p>
-                  </a:txBody>
-                  <a:tcPr/>
-                </a:tc>
-              </a:tr>
-            </a:tbl>
-          </a:graphicData>
-        </a:graphic>
-      </p:graphicFrame>
+      <p:pic>
+        <p:nvPicPr>
+          <p:cNvPr id="7" name="Picture 6" descr="image.png"/>
+          <p:cNvPicPr>
+            <a:picLocks noChangeAspect="1"/>
+          </p:cNvPicPr>
+          <p:nvPr/>
+        </p:nvPicPr>
+        <p:blipFill>
+          <a:blip r:embed="rId2"/>
+          <a:stretch>
+            <a:fillRect/>
+          </a:stretch>
+        </p:blipFill>
+        <p:spPr>
+          <a:xfrm>
+            <a:off x="2163921" y="1325880"/>
+            <a:ext cx="7861110" cy="4937760"/>
+          </a:xfrm>
+          <a:prstGeom prst="rect">
+            <a:avLst/>
+          </a:prstGeom>
+        </p:spPr>
+      </p:pic>
       <p:sp>
         <p:nvSpPr>
           <p:cNvPr id="8" name="Rectangle 7"/>
@@ -9723,7 +9461,7 @@
                 </a:solidFill>
                 <a:latin typeface="Consolas"/>
               </a:rPr>
-              <a:t>Übersicht</a:t>
+              <a:t>Schaubild</a:t>
             </a:r>
           </a:p>
         </p:txBody>
@@ -9983,7 +9721,7 @@
                 </a:solidFill>
                 <a:latin typeface="Arial"/>
               </a:rPr>
-              <a:t>Ampel-Checkliste: Gesamtbewertung Kreditrisiko</a:t>
+              <a:t>Eskalationspfade: wer handelt wann?</a:t>
             </a:r>
           </a:p>
         </p:txBody>
@@ -10009,6 +9747,25 @@
             <a:spAutoFit/>
           </a:bodyPr>
           <a:lstStyle/>
+          <a:p>
+            <a:pPr marL="177800" indent="-177800">
+              <a:spcBef>
+                <a:spcPts val="600"/>
+              </a:spcBef>
+              <a:spcAft>
+                <a:spcPts val="200"/>
+              </a:spcAft>
+            </a:pPr>
+            <a:r>
+              <a:rPr sz="1200" i="1">
+                <a:solidFill>
+                  <a:srgbClr val="3D5466"/>
+                </a:solidFill>
+                <a:latin typeface="Arial"/>
+              </a:rPr>
+              <a:t>→  Ein erkanntes Signal ist wertlos ohne klaren Eskalationspfad – wer wird wann informiert?</a:t>
+            </a:r>
+          </a:p>
           <a:p>
             <a:pPr marL="190500" indent="-190500">
               <a:spcBef>
@@ -10025,26 +9782,45 @@
                 </a:solidFill>
                 <a:latin typeface="Arial"/>
               </a:rPr>
-              <a:t>▸  Anleitung: Bewerten Sie jeden Indikator mit Grün (0 Punkte), Gelb (1 Punkt) oder Rot (2 Punkte).</a:t>
-            </a:r>
-          </a:p>
-          <a:p>
-            <a:pPr marL="177800" indent="-177800">
+              <a:t>▸  Gelb: Beobachtung intensivieren, Risikovermerk in agree, Gespräch suchen.</a:t>
+            </a:r>
+          </a:p>
+          <a:p>
+            <a:pPr marL="190500" indent="-190500">
               <a:spcBef>
-                <a:spcPts val="600"/>
+                <a:spcPts val="400"/>
               </a:spcBef>
               <a:spcAft>
                 <a:spcPts val="200"/>
               </a:spcAft>
             </a:pPr>
             <a:r>
-              <a:rPr sz="1200" i="1">
+              <a:rPr sz="1300">
                 <a:solidFill>
                   <a:srgbClr val="3D5466"/>
                 </a:solidFill>
                 <a:latin typeface="Arial"/>
               </a:rPr>
-              <a:t>→  Einzel-Rot-Trigger: Bei Jahresabschluss-Verweigerung, laufendem Zinsverzug oder Kenntnis eines Insolvenzantrags → unabhängig vom Gesamtscore sofort eskalieren.</a:t>
+              <a:t>▸  Rot: Teamleiter und Marktfolge informieren, keine eigenständigen Zusagen.</a:t>
+            </a:r>
+          </a:p>
+          <a:p>
+            <a:pPr marL="190500" indent="-190500">
+              <a:spcBef>
+                <a:spcPts val="400"/>
+              </a:spcBef>
+              <a:spcAft>
+                <a:spcPts val="200"/>
+              </a:spcAft>
+            </a:pPr>
+            <a:r>
+              <a:rPr sz="1300">
+                <a:solidFill>
+                  <a:srgbClr val="3D5466"/>
+                </a:solidFill>
+                <a:latin typeface="Arial"/>
+              </a:rPr>
+              <a:t>▸  Bei Insolvenzantrag: umgehend die Problemkreditabteilung.</a:t>
             </a:r>
           </a:p>
         </p:txBody>

</xml_diff>